<commit_message>
relations 1.5.4 et bestiary 1.1.8
</commit_message>
<xml_diff>
--- a/Guide_MJ_Ashara.pptx
+++ b/Guide_MJ_Ashara.pptx
@@ -125,12 +125,20 @@
 </p:presentation>
 </file>
 
+<file path=ppt/revisionInfo.xml><?xml version="1.0" encoding="utf-8"?>
+<p1510:revInfo xmlns:a="http://schemas.openxmlformats.org/drawingml/2006/main" xmlns:r="http://schemas.openxmlformats.org/officeDocument/2006/relationships" xmlns:p1510="http://schemas.microsoft.com/office/powerpoint/2015/10/main">
+  <p1510:revLst>
+    <p1510:client id="{97D968E1-7EB2-404B-9820-12B145EA5AF8}" v="2" dt="2026-07-12T18:38:37.596"/>
+  </p1510:revLst>
+</p1510:revInfo>
+</file>
+
 <file path=ppt/changesInfos/changesInfo1.xml><?xml version="1.0" encoding="utf-8"?>
 <pc:chgInfo xmlns:a="http://schemas.openxmlformats.org/drawingml/2006/main" xmlns:r="http://schemas.openxmlformats.org/officeDocument/2006/relationships" xmlns:ac="http://schemas.microsoft.com/office/drawing/2013/main/command" xmlns:pc="http://schemas.microsoft.com/office/powerpoint/2013/main/command">
   <pc:docChgLst>
     <pc:chgData name="Gaétan Viader" userId="697ac9fd9d1a1710" providerId="LiveId" clId="{923574D7-4140-40F2-AB19-D7229FDC6D20}"/>
-    <pc:docChg chg="custSel modSld">
-      <pc:chgData name="Gaétan Viader" userId="697ac9fd9d1a1710" providerId="LiveId" clId="{923574D7-4140-40F2-AB19-D7229FDC6D20}" dt="2026-07-12T18:01:37.719" v="199" actId="20577"/>
+    <pc:docChg chg="undo custSel modSld">
+      <pc:chgData name="Gaétan Viader" userId="697ac9fd9d1a1710" providerId="LiveId" clId="{923574D7-4140-40F2-AB19-D7229FDC6D20}" dt="2026-07-12T18:49:02.694" v="586" actId="1076"/>
       <pc:docMkLst>
         <pc:docMk/>
       </pc:docMkLst>
@@ -197,6 +205,155 @@
         </pc:spChg>
       </pc:sldChg>
       <pc:sldChg chg="delSp modSp mod">
+        <pc:chgData name="Gaétan Viader" userId="697ac9fd9d1a1710" providerId="LiveId" clId="{923574D7-4140-40F2-AB19-D7229FDC6D20}" dt="2026-07-12T18:49:02.694" v="586" actId="1076"/>
+        <pc:sldMkLst>
+          <pc:docMk/>
+          <pc:sldMk cId="0" sldId="259"/>
+        </pc:sldMkLst>
+        <pc:spChg chg="mod">
+          <ac:chgData name="Gaétan Viader" userId="697ac9fd9d1a1710" providerId="LiveId" clId="{923574D7-4140-40F2-AB19-D7229FDC6D20}" dt="2026-07-12T18:32:56.308" v="202" actId="1076"/>
+          <ac:spMkLst>
+            <pc:docMk/>
+            <pc:sldMk cId="0" sldId="259"/>
+            <ac:spMk id="4" creationId="{00000000-0000-0000-0000-000000000000}"/>
+          </ac:spMkLst>
+        </pc:spChg>
+        <pc:spChg chg="del">
+          <ac:chgData name="Gaétan Viader" userId="697ac9fd9d1a1710" providerId="LiveId" clId="{923574D7-4140-40F2-AB19-D7229FDC6D20}" dt="2026-07-12T18:48:50.683" v="585" actId="478"/>
+          <ac:spMkLst>
+            <pc:docMk/>
+            <pc:sldMk cId="0" sldId="259"/>
+            <ac:spMk id="10" creationId="{00000000-0000-0000-0000-000000000000}"/>
+          </ac:spMkLst>
+        </pc:spChg>
+        <pc:spChg chg="del mod">
+          <ac:chgData name="Gaétan Viader" userId="697ac9fd9d1a1710" providerId="LiveId" clId="{923574D7-4140-40F2-AB19-D7229FDC6D20}" dt="2026-07-12T18:48:49.281" v="584" actId="478"/>
+          <ac:spMkLst>
+            <pc:docMk/>
+            <pc:sldMk cId="0" sldId="259"/>
+            <ac:spMk id="11" creationId="{00000000-0000-0000-0000-000000000000}"/>
+          </ac:spMkLst>
+        </pc:spChg>
+        <pc:spChg chg="mod">
+          <ac:chgData name="Gaétan Viader" userId="697ac9fd9d1a1710" providerId="LiveId" clId="{923574D7-4140-40F2-AB19-D7229FDC6D20}" dt="2026-07-12T18:49:02.694" v="586" actId="1076"/>
+          <ac:spMkLst>
+            <pc:docMk/>
+            <pc:sldMk cId="0" sldId="259"/>
+            <ac:spMk id="12" creationId="{00000000-0000-0000-0000-000000000000}"/>
+          </ac:spMkLst>
+        </pc:spChg>
+        <pc:spChg chg="mod">
+          <ac:chgData name="Gaétan Viader" userId="697ac9fd9d1a1710" providerId="LiveId" clId="{923574D7-4140-40F2-AB19-D7229FDC6D20}" dt="2026-07-12T18:49:02.694" v="586" actId="1076"/>
+          <ac:spMkLst>
+            <pc:docMk/>
+            <pc:sldMk cId="0" sldId="259"/>
+            <ac:spMk id="13" creationId="{00000000-0000-0000-0000-000000000000}"/>
+          </ac:spMkLst>
+        </pc:spChg>
+        <pc:spChg chg="mod">
+          <ac:chgData name="Gaétan Viader" userId="697ac9fd9d1a1710" providerId="LiveId" clId="{923574D7-4140-40F2-AB19-D7229FDC6D20}" dt="2026-07-12T18:49:02.694" v="586" actId="1076"/>
+          <ac:spMkLst>
+            <pc:docMk/>
+            <pc:sldMk cId="0" sldId="259"/>
+            <ac:spMk id="14" creationId="{00000000-0000-0000-0000-000000000000}"/>
+          </ac:spMkLst>
+        </pc:spChg>
+        <pc:spChg chg="mod">
+          <ac:chgData name="Gaétan Viader" userId="697ac9fd9d1a1710" providerId="LiveId" clId="{923574D7-4140-40F2-AB19-D7229FDC6D20}" dt="2026-07-12T18:49:02.694" v="586" actId="1076"/>
+          <ac:spMkLst>
+            <pc:docMk/>
+            <pc:sldMk cId="0" sldId="259"/>
+            <ac:spMk id="15" creationId="{00000000-0000-0000-0000-000000000000}"/>
+          </ac:spMkLst>
+        </pc:spChg>
+      </pc:sldChg>
+      <pc:sldChg chg="delSp modSp mod">
+        <pc:chgData name="Gaétan Viader" userId="697ac9fd9d1a1710" providerId="LiveId" clId="{923574D7-4140-40F2-AB19-D7229FDC6D20}" dt="2026-07-12T18:38:57.289" v="425" actId="478"/>
+        <pc:sldMkLst>
+          <pc:docMk/>
+          <pc:sldMk cId="0" sldId="265"/>
+        </pc:sldMkLst>
+        <pc:spChg chg="mod">
+          <ac:chgData name="Gaétan Viader" userId="697ac9fd9d1a1710" providerId="LiveId" clId="{923574D7-4140-40F2-AB19-D7229FDC6D20}" dt="2026-07-12T18:38:54.986" v="424" actId="1076"/>
+          <ac:spMkLst>
+            <pc:docMk/>
+            <pc:sldMk cId="0" sldId="265"/>
+            <ac:spMk id="28" creationId="{00000000-0000-0000-0000-000000000000}"/>
+          </ac:spMkLst>
+        </pc:spChg>
+        <pc:spChg chg="mod">
+          <ac:chgData name="Gaétan Viader" userId="697ac9fd9d1a1710" providerId="LiveId" clId="{923574D7-4140-40F2-AB19-D7229FDC6D20}" dt="2026-07-12T18:34:18.663" v="229" actId="20577"/>
+          <ac:spMkLst>
+            <pc:docMk/>
+            <pc:sldMk cId="0" sldId="265"/>
+            <ac:spMk id="35" creationId="{00000000-0000-0000-0000-000000000000}"/>
+          </ac:spMkLst>
+        </pc:spChg>
+        <pc:spChg chg="mod">
+          <ac:chgData name="Gaétan Viader" userId="697ac9fd9d1a1710" providerId="LiveId" clId="{923574D7-4140-40F2-AB19-D7229FDC6D20}" dt="2026-07-12T18:36:50.889" v="267" actId="20577"/>
+          <ac:spMkLst>
+            <pc:docMk/>
+            <pc:sldMk cId="0" sldId="265"/>
+            <ac:spMk id="37" creationId="{00000000-0000-0000-0000-000000000000}"/>
+          </ac:spMkLst>
+        </pc:spChg>
+        <pc:spChg chg="del">
+          <ac:chgData name="Gaétan Viader" userId="697ac9fd9d1a1710" providerId="LiveId" clId="{923574D7-4140-40F2-AB19-D7229FDC6D20}" dt="2026-07-12T18:38:57.289" v="425" actId="478"/>
+          <ac:spMkLst>
+            <pc:docMk/>
+            <pc:sldMk cId="0" sldId="265"/>
+            <ac:spMk id="38" creationId="{00000000-0000-0000-0000-000000000000}"/>
+          </ac:spMkLst>
+        </pc:spChg>
+        <pc:spChg chg="mod">
+          <ac:chgData name="Gaétan Viader" userId="697ac9fd9d1a1710" providerId="LiveId" clId="{923574D7-4140-40F2-AB19-D7229FDC6D20}" dt="2026-07-12T18:38:30.304" v="418" actId="21"/>
+          <ac:spMkLst>
+            <pc:docMk/>
+            <pc:sldMk cId="0" sldId="265"/>
+            <ac:spMk id="39" creationId="{00000000-0000-0000-0000-000000000000}"/>
+          </ac:spMkLst>
+        </pc:spChg>
+        <pc:spChg chg="mod">
+          <ac:chgData name="Gaétan Viader" userId="697ac9fd9d1a1710" providerId="LiveId" clId="{923574D7-4140-40F2-AB19-D7229FDC6D20}" dt="2026-07-12T18:38:53.347" v="423" actId="20577"/>
+          <ac:spMkLst>
+            <pc:docMk/>
+            <pc:sldMk cId="0" sldId="265"/>
+            <ac:spMk id="41" creationId="{00000000-0000-0000-0000-000000000000}"/>
+          </ac:spMkLst>
+        </pc:spChg>
+      </pc:sldChg>
+      <pc:sldChg chg="modSp mod">
+        <pc:chgData name="Gaétan Viader" userId="697ac9fd9d1a1710" providerId="LiveId" clId="{923574D7-4140-40F2-AB19-D7229FDC6D20}" dt="2026-07-12T18:41:56.011" v="502" actId="20577"/>
+        <pc:sldMkLst>
+          <pc:docMk/>
+          <pc:sldMk cId="0" sldId="266"/>
+        </pc:sldMkLst>
+        <pc:spChg chg="mod">
+          <ac:chgData name="Gaétan Viader" userId="697ac9fd9d1a1710" providerId="LiveId" clId="{923574D7-4140-40F2-AB19-D7229FDC6D20}" dt="2026-07-12T18:41:25.089" v="469" actId="20577"/>
+          <ac:spMkLst>
+            <pc:docMk/>
+            <pc:sldMk cId="0" sldId="266"/>
+            <ac:spMk id="7" creationId="{00000000-0000-0000-0000-000000000000}"/>
+          </ac:spMkLst>
+        </pc:spChg>
+        <pc:spChg chg="mod">
+          <ac:chgData name="Gaétan Viader" userId="697ac9fd9d1a1710" providerId="LiveId" clId="{923574D7-4140-40F2-AB19-D7229FDC6D20}" dt="2026-07-12T18:41:56.011" v="502" actId="20577"/>
+          <ac:spMkLst>
+            <pc:docMk/>
+            <pc:sldMk cId="0" sldId="266"/>
+            <ac:spMk id="9" creationId="{00000000-0000-0000-0000-000000000000}"/>
+          </ac:spMkLst>
+        </pc:spChg>
+        <pc:spChg chg="mod">
+          <ac:chgData name="Gaétan Viader" userId="697ac9fd9d1a1710" providerId="LiveId" clId="{923574D7-4140-40F2-AB19-D7229FDC6D20}" dt="2026-07-12T18:40:09.115" v="448" actId="20577"/>
+          <ac:spMkLst>
+            <pc:docMk/>
+            <pc:sldMk cId="0" sldId="266"/>
+            <ac:spMk id="27" creationId="{00000000-0000-0000-0000-000000000000}"/>
+          </ac:spMkLst>
+        </pc:spChg>
+      </pc:sldChg>
+      <pc:sldChg chg="delSp modSp mod">
         <pc:chgData name="Gaétan Viader" userId="697ac9fd9d1a1710" providerId="LiveId" clId="{923574D7-4140-40F2-AB19-D7229FDC6D20}" dt="2026-07-12T13:56:07.398" v="5" actId="478"/>
         <pc:sldMkLst>
           <pc:docMk/>
@@ -224,6 +381,21 @@
             <pc:docMk/>
             <pc:sldMk cId="0" sldId="268"/>
             <ac:spMk id="31" creationId="{00000000-0000-0000-0000-000000000000}"/>
+          </ac:spMkLst>
+        </pc:spChg>
+      </pc:sldChg>
+      <pc:sldChg chg="modSp mod">
+        <pc:chgData name="Gaétan Viader" userId="697ac9fd9d1a1710" providerId="LiveId" clId="{923574D7-4140-40F2-AB19-D7229FDC6D20}" dt="2026-07-12T18:42:58.589" v="526" actId="20577"/>
+        <pc:sldMkLst>
+          <pc:docMk/>
+          <pc:sldMk cId="0" sldId="269"/>
+        </pc:sldMkLst>
+        <pc:spChg chg="mod">
+          <ac:chgData name="Gaétan Viader" userId="697ac9fd9d1a1710" providerId="LiveId" clId="{923574D7-4140-40F2-AB19-D7229FDC6D20}" dt="2026-07-12T18:42:58.589" v="526" actId="20577"/>
+          <ac:spMkLst>
+            <pc:docMk/>
+            <pc:sldMk cId="0" sldId="269"/>
+            <ac:spMk id="8" creationId="{00000000-0000-0000-0000-000000000000}"/>
           </ac:spMkLst>
         </pc:spChg>
       </pc:sldChg>
@@ -3345,7 +3517,7 @@
         </p:nvSpPr>
         <p:spPr>
           <a:xfrm>
-            <a:off x="6080760" y="1325880"/>
+            <a:off x="6080760" y="1322832"/>
             <a:ext cx="2651760" cy="2880360"/>
           </a:xfrm>
           <a:prstGeom prst="rect">
@@ -3629,7 +3801,51 @@
                 <a:ea typeface="Calibri" pitchFamily="34" charset="-122"/>
                 <a:cs typeface="Calibri" pitchFamily="34" charset="-120"/>
               </a:rPr>
-              <a:t>Craft -&gt; items dans l'inventaire</a:t>
+              <a:t>Craft -&gt; items à </a:t>
+            </a:r>
+            <a:r>
+              <a:rPr lang="en-US" sz="1100" dirty="0" err="1">
+                <a:solidFill>
+                  <a:srgbClr val="F0F6FC"/>
+                </a:solidFill>
+                <a:latin typeface="Calibri" pitchFamily="34" charset="0"/>
+                <a:ea typeface="Calibri" pitchFamily="34" charset="-122"/>
+                <a:cs typeface="Calibri" pitchFamily="34" charset="-120"/>
+              </a:rPr>
+              <a:t>mettre</a:t>
+            </a:r>
+            <a:r>
+              <a:rPr lang="en-US" sz="1100" dirty="0">
+                <a:solidFill>
+                  <a:srgbClr val="F0F6FC"/>
+                </a:solidFill>
+                <a:latin typeface="Calibri" pitchFamily="34" charset="0"/>
+                <a:ea typeface="Calibri" pitchFamily="34" charset="-122"/>
+                <a:cs typeface="Calibri" pitchFamily="34" charset="-120"/>
+              </a:rPr>
+              <a:t> dans </a:t>
+            </a:r>
+            <a:r>
+              <a:rPr lang="en-US" sz="1100" dirty="0" err="1">
+                <a:solidFill>
+                  <a:srgbClr val="F0F6FC"/>
+                </a:solidFill>
+                <a:latin typeface="Calibri" pitchFamily="34" charset="0"/>
+                <a:ea typeface="Calibri" pitchFamily="34" charset="-122"/>
+                <a:cs typeface="Calibri" pitchFamily="34" charset="-120"/>
+              </a:rPr>
+              <a:t>l'inventaire</a:t>
+            </a:r>
+            <a:r>
+              <a:rPr lang="en-US" sz="1100" dirty="0">
+                <a:solidFill>
+                  <a:srgbClr val="F0F6FC"/>
+                </a:solidFill>
+                <a:latin typeface="Calibri" pitchFamily="34" charset="0"/>
+                <a:ea typeface="Calibri" pitchFamily="34" charset="-122"/>
+                <a:cs typeface="Calibri" pitchFamily="34" charset="-120"/>
+              </a:rPr>
+              <a:t> par un GM</a:t>
             </a:r>
             <a:endParaRPr lang="en-US" sz="1100" dirty="0"/>
           </a:p>
@@ -3699,6 +3915,17 @@
               <a:buNone/>
             </a:pPr>
             <a:r>
+              <a:rPr lang="en-US" sz="1100" dirty="0" err="1">
+                <a:solidFill>
+                  <a:srgbClr val="F0F6FC"/>
+                </a:solidFill>
+                <a:latin typeface="Calibri" pitchFamily="34" charset="0"/>
+                <a:ea typeface="Calibri" pitchFamily="34" charset="-122"/>
+                <a:cs typeface="Calibri" pitchFamily="34" charset="-120"/>
+              </a:rPr>
+              <a:t>Resultat</a:t>
+            </a:r>
+            <a:r>
               <a:rPr lang="en-US" sz="1100" dirty="0">
                 <a:solidFill>
                   <a:srgbClr val="F0F6FC"/>
@@ -3707,46 +3934,29 @@
                 <a:ea typeface="Calibri" pitchFamily="34" charset="-122"/>
                 <a:cs typeface="Calibri" pitchFamily="34" charset="-120"/>
               </a:rPr>
-              <a:t>Aucune manipulation manuelle</a:t>
-            </a:r>
-            <a:endParaRPr lang="en-US" sz="1100" dirty="0"/>
-          </a:p>
-        </p:txBody>
-      </p:sp>
-      <p:sp>
-        <p:nvSpPr>
-          <p:cNvPr id="38" name="Text 36"/>
-          <p:cNvSpPr/>
-          <p:nvPr/>
-        </p:nvSpPr>
-        <p:spPr>
-          <a:xfrm>
-            <a:off x="6217920" y="3630168"/>
-            <a:ext cx="256032" cy="329184"/>
-          </a:xfrm>
-          <a:prstGeom prst="rect">
-            <a:avLst/>
-          </a:prstGeom>
-          <a:noFill/>
-          <a:ln/>
-        </p:spPr>
-        <p:txBody>
-          <a:bodyPr wrap="square" lIns="0" tIns="0" rIns="0" bIns="0" rtlCol="0" anchor="ctr"/>
-          <a:lstStyle/>
-          <a:p>
-            <a:pPr marL="0" indent="0" algn="ctr">
-              <a:buNone/>
-            </a:pPr>
+              <a:t> dans le </a:t>
+            </a:r>
+            <a:r>
+              <a:rPr lang="en-US" sz="1100" dirty="0" err="1">
+                <a:solidFill>
+                  <a:srgbClr val="F0F6FC"/>
+                </a:solidFill>
+                <a:latin typeface="Calibri" pitchFamily="34" charset="0"/>
+                <a:ea typeface="Calibri" pitchFamily="34" charset="-122"/>
+                <a:cs typeface="Calibri" pitchFamily="34" charset="-120"/>
+              </a:rPr>
+              <a:t>tchat</a:t>
+            </a:r>
             <a:r>
               <a:rPr lang="en-US" sz="1100" dirty="0">
                 <a:solidFill>
-                  <a:srgbClr val="00B4D8"/>
-                </a:solidFill>
-                <a:latin typeface="Calibri" pitchFamily="34" charset="0"/>
-                <a:ea typeface="Calibri" pitchFamily="34" charset="-122"/>
-                <a:cs typeface="Calibri" pitchFamily="34" charset="-120"/>
-              </a:rPr>
-              <a:t>&gt;</a:t>
+                  <a:srgbClr val="F0F6FC"/>
+                </a:solidFill>
+                <a:latin typeface="Calibri" pitchFamily="34" charset="0"/>
+                <a:ea typeface="Calibri" pitchFamily="34" charset="-122"/>
+                <a:cs typeface="Calibri" pitchFamily="34" charset="-120"/>
+              </a:rPr>
+              <a:t> et le discord</a:t>
             </a:r>
             <a:endParaRPr lang="en-US" sz="1100" dirty="0"/>
           </a:p>
@@ -3776,17 +3986,6 @@
             <a:pPr marL="0" indent="0">
               <a:buNone/>
             </a:pPr>
-            <a:r>
-              <a:rPr lang="en-US" sz="1100" dirty="0">
-                <a:solidFill>
-                  <a:srgbClr val="F0F6FC"/>
-                </a:solidFill>
-                <a:latin typeface="Calibri" pitchFamily="34" charset="0"/>
-                <a:ea typeface="Calibri" pitchFamily="34" charset="-122"/>
-                <a:cs typeface="Calibri" pitchFamily="34" charset="-120"/>
-              </a:rPr>
-              <a:t>Resultat visible sur la fiche du PJ</a:t>
-            </a:r>
             <a:endParaRPr lang="en-US" sz="1100" dirty="0"/>
           </a:p>
         </p:txBody>
@@ -3844,21 +4043,249 @@
           <a:bodyPr wrap="square" lIns="0" tIns="0" rIns="0" bIns="0" rtlCol="0" anchor="ctr"/>
           <a:lstStyle/>
           <a:p>
-            <a:pPr marL="0" indent="0">
-              <a:buNone/>
-            </a:pPr>
-            <a:r>
-              <a:rPr lang="en-US" sz="1150" dirty="0">
-                <a:solidFill>
-                  <a:srgbClr val="F0F6FC"/>
-                </a:solidFill>
-                <a:latin typeface="Calibri" pitchFamily="34" charset="0"/>
-                <a:ea typeface="Calibri" pitchFamily="34" charset="-122"/>
-                <a:cs typeface="Calibri" pitchFamily="34" charset="-120"/>
-              </a:rPr>
-              <a:t>Acces : icones de gauche sur le canvas -&gt; onglet Temps Morts | Disponible pour les joueurs et le MJ</a:t>
-            </a:r>
-            <a:endParaRPr lang="en-US" sz="1150" dirty="0"/>
+            <a:r>
+              <a:rPr lang="en-US" sz="1200" dirty="0">
+                <a:solidFill>
+                  <a:srgbClr val="F0F6FC"/>
+                </a:solidFill>
+                <a:latin typeface="Calibri" pitchFamily="34" charset="0"/>
+                <a:ea typeface="Calibri" pitchFamily="34" charset="-122"/>
+                <a:cs typeface="Calibri" pitchFamily="34" charset="-120"/>
+              </a:rPr>
+              <a:t>Attention, </a:t>
+            </a:r>
+            <a:r>
+              <a:rPr lang="en-US" sz="1200" dirty="0" err="1">
+                <a:solidFill>
+                  <a:srgbClr val="F0F6FC"/>
+                </a:solidFill>
+                <a:latin typeface="Calibri" pitchFamily="34" charset="0"/>
+                <a:ea typeface="Calibri" pitchFamily="34" charset="-122"/>
+                <a:cs typeface="Calibri" pitchFamily="34" charset="-120"/>
+              </a:rPr>
+              <a:t>si</a:t>
+            </a:r>
+            <a:r>
+              <a:rPr lang="en-US" sz="1200" dirty="0">
+                <a:solidFill>
+                  <a:srgbClr val="F0F6FC"/>
+                </a:solidFill>
+                <a:latin typeface="Calibri" pitchFamily="34" charset="0"/>
+                <a:ea typeface="Calibri" pitchFamily="34" charset="-122"/>
+                <a:cs typeface="Calibri" pitchFamily="34" charset="-120"/>
+              </a:rPr>
+              <a:t> un </a:t>
+            </a:r>
+            <a:r>
+              <a:rPr lang="en-US" sz="1200" dirty="0" err="1">
+                <a:solidFill>
+                  <a:srgbClr val="F0F6FC"/>
+                </a:solidFill>
+                <a:latin typeface="Calibri" pitchFamily="34" charset="0"/>
+                <a:ea typeface="Calibri" pitchFamily="34" charset="-122"/>
+                <a:cs typeface="Calibri" pitchFamily="34" charset="-120"/>
+              </a:rPr>
+              <a:t>joueur</a:t>
+            </a:r>
+            <a:r>
+              <a:rPr lang="en-US" sz="1200" dirty="0">
+                <a:solidFill>
+                  <a:srgbClr val="F0F6FC"/>
+                </a:solidFill>
+                <a:latin typeface="Calibri" pitchFamily="34" charset="0"/>
+                <a:ea typeface="Calibri" pitchFamily="34" charset="-122"/>
+                <a:cs typeface="Calibri" pitchFamily="34" charset="-120"/>
+              </a:rPr>
+              <a:t> </a:t>
+            </a:r>
+            <a:r>
+              <a:rPr lang="en-US" sz="1200" dirty="0" err="1">
+                <a:solidFill>
+                  <a:srgbClr val="F0F6FC"/>
+                </a:solidFill>
+                <a:latin typeface="Calibri" pitchFamily="34" charset="0"/>
+                <a:ea typeface="Calibri" pitchFamily="34" charset="-122"/>
+                <a:cs typeface="Calibri" pitchFamily="34" charset="-120"/>
+              </a:rPr>
+              <a:t>n’a</a:t>
+            </a:r>
+            <a:r>
+              <a:rPr lang="en-US" sz="1200" dirty="0">
+                <a:solidFill>
+                  <a:srgbClr val="F0F6FC"/>
+                </a:solidFill>
+                <a:latin typeface="Calibri" pitchFamily="34" charset="0"/>
+                <a:ea typeface="Calibri" pitchFamily="34" charset="-122"/>
+                <a:cs typeface="Calibri" pitchFamily="34" charset="-120"/>
+              </a:rPr>
+              <a:t> pas </a:t>
+            </a:r>
+            <a:r>
+              <a:rPr lang="en-US" sz="1200" dirty="0" err="1">
+                <a:solidFill>
+                  <a:srgbClr val="F0F6FC"/>
+                </a:solidFill>
+                <a:latin typeface="Calibri" pitchFamily="34" charset="0"/>
+                <a:ea typeface="Calibri" pitchFamily="34" charset="-122"/>
+                <a:cs typeface="Calibri" pitchFamily="34" charset="-120"/>
+              </a:rPr>
+              <a:t>d’argent</a:t>
+            </a:r>
+            <a:r>
+              <a:rPr lang="en-US" sz="1200" dirty="0">
+                <a:solidFill>
+                  <a:srgbClr val="F0F6FC"/>
+                </a:solidFill>
+                <a:latin typeface="Calibri" pitchFamily="34" charset="0"/>
+                <a:ea typeface="Calibri" pitchFamily="34" charset="-122"/>
+                <a:cs typeface="Calibri" pitchFamily="34" charset="-120"/>
+              </a:rPr>
+              <a:t> dans </a:t>
+            </a:r>
+            <a:r>
+              <a:rPr lang="en-US" sz="1200" dirty="0" err="1">
+                <a:solidFill>
+                  <a:srgbClr val="F0F6FC"/>
+                </a:solidFill>
+                <a:latin typeface="Calibri" pitchFamily="34" charset="0"/>
+                <a:ea typeface="Calibri" pitchFamily="34" charset="-122"/>
+                <a:cs typeface="Calibri" pitchFamily="34" charset="-120"/>
+              </a:rPr>
+              <a:t>l’endroit</a:t>
+            </a:r>
+            <a:r>
+              <a:rPr lang="en-US" sz="1200" dirty="0">
+                <a:solidFill>
+                  <a:srgbClr val="F0F6FC"/>
+                </a:solidFill>
+                <a:latin typeface="Calibri" pitchFamily="34" charset="0"/>
+                <a:ea typeface="Calibri" pitchFamily="34" charset="-122"/>
+                <a:cs typeface="Calibri" pitchFamily="34" charset="-120"/>
+              </a:rPr>
+              <a:t> principal </a:t>
+            </a:r>
+            <a:r>
+              <a:rPr lang="en-US" sz="1200" dirty="0" err="1">
+                <a:solidFill>
+                  <a:srgbClr val="F0F6FC"/>
+                </a:solidFill>
+                <a:latin typeface="Calibri" pitchFamily="34" charset="0"/>
+                <a:ea typeface="Calibri" pitchFamily="34" charset="-122"/>
+                <a:cs typeface="Calibri" pitchFamily="34" charset="-120"/>
+              </a:rPr>
+              <a:t>mais</a:t>
+            </a:r>
+            <a:r>
+              <a:rPr lang="en-US" sz="1200" dirty="0">
+                <a:solidFill>
+                  <a:srgbClr val="F0F6FC"/>
+                </a:solidFill>
+                <a:latin typeface="Calibri" pitchFamily="34" charset="0"/>
+                <a:ea typeface="Calibri" pitchFamily="34" charset="-122"/>
+                <a:cs typeface="Calibri" pitchFamily="34" charset="-120"/>
+              </a:rPr>
+              <a:t> dans </a:t>
+            </a:r>
+            <a:r>
+              <a:rPr lang="en-US" sz="1200" dirty="0" err="1">
+                <a:solidFill>
+                  <a:srgbClr val="F0F6FC"/>
+                </a:solidFill>
+                <a:latin typeface="Calibri" pitchFamily="34" charset="0"/>
+                <a:ea typeface="Calibri" pitchFamily="34" charset="-122"/>
+                <a:cs typeface="Calibri" pitchFamily="34" charset="-120"/>
+              </a:rPr>
+              <a:t>une</a:t>
+            </a:r>
+            <a:r>
+              <a:rPr lang="en-US" sz="1200" dirty="0">
+                <a:solidFill>
+                  <a:srgbClr val="F0F6FC"/>
+                </a:solidFill>
+                <a:latin typeface="Calibri" pitchFamily="34" charset="0"/>
+                <a:ea typeface="Calibri" pitchFamily="34" charset="-122"/>
+                <a:cs typeface="Calibri" pitchFamily="34" charset="-120"/>
+              </a:rPr>
+              <a:t> pouch </a:t>
+            </a:r>
+            <a:r>
+              <a:rPr lang="en-US" sz="1200" dirty="0" err="1">
+                <a:solidFill>
+                  <a:srgbClr val="F0F6FC"/>
+                </a:solidFill>
+                <a:latin typeface="Calibri" pitchFamily="34" charset="0"/>
+                <a:ea typeface="Calibri" pitchFamily="34" charset="-122"/>
+                <a:cs typeface="Calibri" pitchFamily="34" charset="-120"/>
+              </a:rPr>
+              <a:t>ou</a:t>
+            </a:r>
+            <a:r>
+              <a:rPr lang="en-US" sz="1200" dirty="0">
+                <a:solidFill>
+                  <a:srgbClr val="F0F6FC"/>
+                </a:solidFill>
+                <a:latin typeface="Calibri" pitchFamily="34" charset="0"/>
+                <a:ea typeface="Calibri" pitchFamily="34" charset="-122"/>
+                <a:cs typeface="Calibri" pitchFamily="34" charset="-120"/>
+              </a:rPr>
+              <a:t> </a:t>
+            </a:r>
+            <a:r>
+              <a:rPr lang="en-US" sz="1200" dirty="0" err="1">
+                <a:solidFill>
+                  <a:srgbClr val="F0F6FC"/>
+                </a:solidFill>
+                <a:latin typeface="Calibri" pitchFamily="34" charset="0"/>
+                <a:ea typeface="Calibri" pitchFamily="34" charset="-122"/>
+                <a:cs typeface="Calibri" pitchFamily="34" charset="-120"/>
+              </a:rPr>
+              <a:t>autre</a:t>
+            </a:r>
+            <a:r>
+              <a:rPr lang="en-US" sz="1200" dirty="0">
+                <a:solidFill>
+                  <a:srgbClr val="F0F6FC"/>
+                </a:solidFill>
+                <a:latin typeface="Calibri" pitchFamily="34" charset="0"/>
+                <a:ea typeface="Calibri" pitchFamily="34" charset="-122"/>
+                <a:cs typeface="Calibri" pitchFamily="34" charset="-120"/>
+              </a:rPr>
+              <a:t>, il </a:t>
+            </a:r>
+            <a:r>
+              <a:rPr lang="en-US" sz="1200" dirty="0" err="1">
+                <a:solidFill>
+                  <a:srgbClr val="F0F6FC"/>
+                </a:solidFill>
+                <a:latin typeface="Calibri" pitchFamily="34" charset="0"/>
+                <a:ea typeface="Calibri" pitchFamily="34" charset="-122"/>
+                <a:cs typeface="Calibri" pitchFamily="34" charset="-120"/>
+              </a:rPr>
+              <a:t>n’est</a:t>
+            </a:r>
+            <a:r>
+              <a:rPr lang="en-US" sz="1200" dirty="0">
+                <a:solidFill>
+                  <a:srgbClr val="F0F6FC"/>
+                </a:solidFill>
+                <a:latin typeface="Calibri" pitchFamily="34" charset="0"/>
+                <a:ea typeface="Calibri" pitchFamily="34" charset="-122"/>
+                <a:cs typeface="Calibri" pitchFamily="34" charset="-120"/>
+              </a:rPr>
+              <a:t> pas </a:t>
+            </a:r>
+            <a:r>
+              <a:rPr lang="en-US" sz="1200" dirty="0" err="1">
+                <a:solidFill>
+                  <a:srgbClr val="F0F6FC"/>
+                </a:solidFill>
+                <a:latin typeface="Calibri" pitchFamily="34" charset="0"/>
+                <a:ea typeface="Calibri" pitchFamily="34" charset="-122"/>
+                <a:cs typeface="Calibri" pitchFamily="34" charset="-120"/>
+              </a:rPr>
+              <a:t>retiré</a:t>
+            </a:r>
+            <a:endParaRPr lang="en-US" sz="1200" dirty="0"/>
           </a:p>
         </p:txBody>
       </p:sp>
@@ -4116,7 +4543,7 @@
                 <a:ea typeface="Calibri" pitchFamily="34" charset="-122"/>
                 <a:cs typeface="Calibri" pitchFamily="34" charset="-120"/>
               </a:rPr>
-              <a:t>Saisir le montant gagne en pieces</a:t>
+              <a:t>Faire son temps morts</a:t>
             </a:r>
             <a:endParaRPr lang="en-US" sz="1300" dirty="0"/>
           </a:p>
@@ -4194,7 +4621,7 @@
                 <a:ea typeface="Calibri" pitchFamily="34" charset="-122"/>
                 <a:cs typeface="Calibri" pitchFamily="34" charset="-120"/>
               </a:rPr>
-              <a:t>Ajouter une note justificative (optionnel)</a:t>
+              <a:t>Lancer un jet pour le bonus</a:t>
             </a:r>
             <a:endParaRPr lang="en-US" sz="1300" dirty="0"/>
           </a:p>
@@ -4889,7 +5316,73 @@
                 <a:ea typeface="Calibri" pitchFamily="34" charset="-122"/>
                 <a:cs typeface="Calibri" pitchFamily="34" charset="-120"/>
               </a:rPr>
-              <a:t>Apres validation : items dans l'inventaire</a:t>
+              <a:t>Apres validation : Le GM </a:t>
+            </a:r>
+            <a:r>
+              <a:rPr lang="en-US" sz="1300" dirty="0" err="1">
+                <a:solidFill>
+                  <a:srgbClr val="F0F6FC"/>
+                </a:solidFill>
+                <a:latin typeface="Calibri" pitchFamily="34" charset="0"/>
+                <a:ea typeface="Calibri" pitchFamily="34" charset="-122"/>
+                <a:cs typeface="Calibri" pitchFamily="34" charset="-120"/>
+              </a:rPr>
+              <a:t>importe</a:t>
+            </a:r>
+            <a:r>
+              <a:rPr lang="en-US" sz="1300" dirty="0">
+                <a:solidFill>
+                  <a:srgbClr val="F0F6FC"/>
+                </a:solidFill>
+                <a:latin typeface="Calibri" pitchFamily="34" charset="0"/>
+                <a:ea typeface="Calibri" pitchFamily="34" charset="-122"/>
+                <a:cs typeface="Calibri" pitchFamily="34" charset="-120"/>
+              </a:rPr>
+              <a:t> </a:t>
+            </a:r>
+            <a:r>
+              <a:rPr lang="en-US" sz="1300" dirty="0" err="1">
+                <a:solidFill>
+                  <a:srgbClr val="F0F6FC"/>
+                </a:solidFill>
+                <a:latin typeface="Calibri" pitchFamily="34" charset="0"/>
+                <a:ea typeface="Calibri" pitchFamily="34" charset="-122"/>
+                <a:cs typeface="Calibri" pitchFamily="34" charset="-120"/>
+              </a:rPr>
+              <a:t>l’items</a:t>
+            </a:r>
+            <a:r>
+              <a:rPr lang="en-US" sz="1300" dirty="0">
+                <a:solidFill>
+                  <a:srgbClr val="F0F6FC"/>
+                </a:solidFill>
+                <a:latin typeface="Calibri" pitchFamily="34" charset="0"/>
+                <a:ea typeface="Calibri" pitchFamily="34" charset="-122"/>
+                <a:cs typeface="Calibri" pitchFamily="34" charset="-120"/>
+              </a:rPr>
+              <a:t> dans </a:t>
+            </a:r>
+            <a:r>
+              <a:rPr lang="en-US" sz="1300" dirty="0" err="1">
+                <a:solidFill>
+                  <a:srgbClr val="F0F6FC"/>
+                </a:solidFill>
+                <a:latin typeface="Calibri" pitchFamily="34" charset="0"/>
+                <a:ea typeface="Calibri" pitchFamily="34" charset="-122"/>
+                <a:cs typeface="Calibri" pitchFamily="34" charset="-120"/>
+              </a:rPr>
+              <a:t>l'inventaire</a:t>
+            </a:r>
+            <a:r>
+              <a:rPr lang="en-US" sz="1300" dirty="0">
+                <a:solidFill>
+                  <a:srgbClr val="F0F6FC"/>
+                </a:solidFill>
+                <a:latin typeface="Calibri" pitchFamily="34" charset="0"/>
+                <a:ea typeface="Calibri" pitchFamily="34" charset="-122"/>
+                <a:cs typeface="Calibri" pitchFamily="34" charset="-120"/>
+              </a:rPr>
+              <a:t> du PJ</a:t>
             </a:r>
             <a:endParaRPr lang="en-US" sz="1300" dirty="0"/>
           </a:p>
@@ -7191,7 +7684,51 @@
                 <a:ea typeface="Calibri" pitchFamily="34" charset="-122"/>
                 <a:cs typeface="Calibri" pitchFamily="34" charset="-120"/>
               </a:rPr>
-              <a:t>Detection auto quand le joueur voit un token PJ/PNJ</a:t>
+              <a:t>Detection auto quand le </a:t>
+            </a:r>
+            <a:r>
+              <a:rPr lang="en-US" sz="1300" dirty="0" err="1">
+                <a:solidFill>
+                  <a:srgbClr val="F0F6FC"/>
+                </a:solidFill>
+                <a:latin typeface="Calibri" pitchFamily="34" charset="0"/>
+                <a:ea typeface="Calibri" pitchFamily="34" charset="-122"/>
+                <a:cs typeface="Calibri" pitchFamily="34" charset="-120"/>
+              </a:rPr>
+              <a:t>joueur</a:t>
+            </a:r>
+            <a:r>
+              <a:rPr lang="en-US" sz="1300" dirty="0">
+                <a:solidFill>
+                  <a:srgbClr val="F0F6FC"/>
+                </a:solidFill>
+                <a:latin typeface="Calibri" pitchFamily="34" charset="0"/>
+                <a:ea typeface="Calibri" pitchFamily="34" charset="-122"/>
+                <a:cs typeface="Calibri" pitchFamily="34" charset="-120"/>
+              </a:rPr>
+              <a:t> rejoin </a:t>
+            </a:r>
+            <a:r>
+              <a:rPr lang="en-US" sz="1300" dirty="0" err="1">
+                <a:solidFill>
+                  <a:srgbClr val="F0F6FC"/>
+                </a:solidFill>
+                <a:latin typeface="Calibri" pitchFamily="34" charset="0"/>
+                <a:ea typeface="Calibri" pitchFamily="34" charset="-122"/>
+                <a:cs typeface="Calibri" pitchFamily="34" charset="-120"/>
+              </a:rPr>
+              <a:t>une</a:t>
+            </a:r>
+            <a:r>
+              <a:rPr lang="en-US" sz="1300" dirty="0">
+                <a:solidFill>
+                  <a:srgbClr val="F0F6FC"/>
+                </a:solidFill>
+                <a:latin typeface="Calibri" pitchFamily="34" charset="0"/>
+                <a:ea typeface="Calibri" pitchFamily="34" charset="-122"/>
+                <a:cs typeface="Calibri" pitchFamily="34" charset="-120"/>
+              </a:rPr>
+              <a:t> scene avec un token PJ/PNJ</a:t>
             </a:r>
             <a:endParaRPr lang="en-US" sz="1300" dirty="0"/>
           </a:p>
@@ -10194,7 +10731,7 @@
           <a:bodyPr/>
           <a:lstStyle/>
           <a:p>
-            <a:endParaRPr lang="fr-FR"/>
+            <a:endParaRPr lang="fr-FR" dirty="0"/>
           </a:p>
         </p:txBody>
       </p:sp>
@@ -10395,13 +10932,13 @@
       </p:sp>
       <p:sp>
         <p:nvSpPr>
-          <p:cNvPr id="10" name="Text 8"/>
-          <p:cNvSpPr/>
-          <p:nvPr/>
-        </p:nvSpPr>
-        <p:spPr>
-          <a:xfrm>
-            <a:off x="502920" y="2761488"/>
+          <p:cNvPr id="12" name="Text 10"/>
+          <p:cNvSpPr/>
+          <p:nvPr/>
+        </p:nvSpPr>
+        <p:spPr>
+          <a:xfrm>
+            <a:off x="502920" y="2759395"/>
             <a:ext cx="320040" cy="347472"/>
           </a:xfrm>
           <a:prstGeom prst="rect">
@@ -10434,13 +10971,13 @@
       </p:sp>
       <p:sp>
         <p:nvSpPr>
-          <p:cNvPr id="11" name="Text 9"/>
-          <p:cNvSpPr/>
-          <p:nvPr/>
-        </p:nvSpPr>
-        <p:spPr>
-          <a:xfrm>
-            <a:off x="850392" y="2761488"/>
+          <p:cNvPr id="13" name="Text 11"/>
+          <p:cNvSpPr/>
+          <p:nvPr/>
+        </p:nvSpPr>
+        <p:spPr>
+          <a:xfrm>
+            <a:off x="850392" y="2759395"/>
             <a:ext cx="3401568" cy="347472"/>
           </a:xfrm>
           <a:prstGeom prst="rect">
@@ -10457,6 +10994,17 @@
               <a:buNone/>
             </a:pPr>
             <a:r>
+              <a:rPr lang="en-US" sz="1300" dirty="0" err="1">
+                <a:solidFill>
+                  <a:srgbClr val="F0F6FC"/>
+                </a:solidFill>
+                <a:latin typeface="Calibri" pitchFamily="34" charset="0"/>
+                <a:ea typeface="Calibri" pitchFamily="34" charset="-122"/>
+                <a:cs typeface="Calibri" pitchFamily="34" charset="-120"/>
+              </a:rPr>
+              <a:t>Afficher</a:t>
+            </a:r>
+            <a:r>
               <a:rPr lang="en-US" sz="1300" dirty="0">
                 <a:solidFill>
                   <a:srgbClr val="F0F6FC"/>
@@ -10465,7 +11013,51 @@
                 <a:ea typeface="Calibri" pitchFamily="34" charset="-122"/>
                 <a:cs typeface="Calibri" pitchFamily="34" charset="-120"/>
               </a:rPr>
-              <a:t>Vision individuelle par joueur (LOS)</a:t>
+              <a:t> dans la </a:t>
+            </a:r>
+            <a:r>
+              <a:rPr lang="en-US" sz="1300" dirty="0" err="1">
+                <a:solidFill>
+                  <a:srgbClr val="F0F6FC"/>
+                </a:solidFill>
+                <a:latin typeface="Calibri" pitchFamily="34" charset="0"/>
+                <a:ea typeface="Calibri" pitchFamily="34" charset="-122"/>
+                <a:cs typeface="Calibri" pitchFamily="34" charset="-120"/>
+              </a:rPr>
+              <a:t>liste</a:t>
+            </a:r>
+            <a:r>
+              <a:rPr lang="en-US" sz="1300" dirty="0">
+                <a:solidFill>
+                  <a:srgbClr val="F0F6FC"/>
+                </a:solidFill>
+                <a:latin typeface="Calibri" pitchFamily="34" charset="0"/>
+                <a:ea typeface="Calibri" pitchFamily="34" charset="-122"/>
+                <a:cs typeface="Calibri" pitchFamily="34" charset="-120"/>
+              </a:rPr>
+              <a:t> </a:t>
+            </a:r>
+            <a:r>
+              <a:rPr lang="en-US" sz="1300" dirty="0" err="1">
+                <a:solidFill>
+                  <a:srgbClr val="F0F6FC"/>
+                </a:solidFill>
+                <a:latin typeface="Calibri" pitchFamily="34" charset="0"/>
+                <a:ea typeface="Calibri" pitchFamily="34" charset="-122"/>
+                <a:cs typeface="Calibri" pitchFamily="34" charset="-120"/>
+              </a:rPr>
+              <a:t>quand</a:t>
+            </a:r>
+            <a:r>
+              <a:rPr lang="en-US" sz="1300" dirty="0">
+                <a:solidFill>
+                  <a:srgbClr val="F0F6FC"/>
+                </a:solidFill>
+                <a:latin typeface="Calibri" pitchFamily="34" charset="0"/>
+                <a:ea typeface="Calibri" pitchFamily="34" charset="-122"/>
+                <a:cs typeface="Calibri" pitchFamily="34" charset="-120"/>
+              </a:rPr>
+              <a:t> le token est sur la scene</a:t>
             </a:r>
             <a:endParaRPr lang="en-US" sz="1300" dirty="0"/>
           </a:p>
@@ -10473,13 +11065,13 @@
       </p:sp>
       <p:sp>
         <p:nvSpPr>
-          <p:cNvPr id="12" name="Text 10"/>
-          <p:cNvSpPr/>
-          <p:nvPr/>
-        </p:nvSpPr>
-        <p:spPr>
-          <a:xfrm>
-            <a:off x="502920" y="3236976"/>
+          <p:cNvPr id="14" name="Text 12"/>
+          <p:cNvSpPr/>
+          <p:nvPr/>
+        </p:nvSpPr>
+        <p:spPr>
+          <a:xfrm>
+            <a:off x="502920" y="3234883"/>
             <a:ext cx="320040" cy="347472"/>
           </a:xfrm>
           <a:prstGeom prst="rect">
@@ -10512,13 +11104,13 @@
       </p:sp>
       <p:sp>
         <p:nvSpPr>
-          <p:cNvPr id="13" name="Text 11"/>
-          <p:cNvSpPr/>
-          <p:nvPr/>
-        </p:nvSpPr>
-        <p:spPr>
-          <a:xfrm>
-            <a:off x="850392" y="3236976"/>
+          <p:cNvPr id="15" name="Text 13"/>
+          <p:cNvSpPr/>
+          <p:nvPr/>
+        </p:nvSpPr>
+        <p:spPr>
+          <a:xfrm>
+            <a:off x="850392" y="3234883"/>
             <a:ext cx="3401568" cy="347472"/>
           </a:xfrm>
           <a:prstGeom prst="rect">
@@ -10531,9 +11123,17 @@
           <a:bodyPr wrap="square" lIns="0" tIns="0" rIns="0" bIns="0" rtlCol="0" anchor="ctr"/>
           <a:lstStyle/>
           <a:p>
-            <a:pPr marL="0" indent="0">
-              <a:buNone/>
-            </a:pPr>
+            <a:r>
+              <a:rPr lang="en-US" sz="1300" dirty="0" err="1">
+                <a:solidFill>
+                  <a:srgbClr val="F0F6FC"/>
+                </a:solidFill>
+                <a:latin typeface="Calibri" pitchFamily="34" charset="0"/>
+                <a:ea typeface="Calibri" pitchFamily="34" charset="-122"/>
+                <a:cs typeface="Calibri" pitchFamily="34" charset="-120"/>
+              </a:rPr>
+              <a:t>Cocher</a:t>
+            </a:r>
             <a:r>
               <a:rPr lang="en-US" sz="1300" dirty="0">
                 <a:solidFill>
@@ -10543,75 +11143,19 @@
                 <a:ea typeface="Calibri" pitchFamily="34" charset="-122"/>
                 <a:cs typeface="Calibri" pitchFamily="34" charset="-120"/>
               </a:rPr>
-              <a:t>Ligne de vue + brouillard de guerre leve requis</a:t>
-            </a:r>
-            <a:endParaRPr lang="en-US" sz="1300" dirty="0"/>
-          </a:p>
-        </p:txBody>
-      </p:sp>
-      <p:sp>
-        <p:nvSpPr>
-          <p:cNvPr id="14" name="Text 12"/>
-          <p:cNvSpPr/>
-          <p:nvPr/>
-        </p:nvSpPr>
-        <p:spPr>
-          <a:xfrm>
-            <a:off x="502920" y="3712464"/>
-            <a:ext cx="320040" cy="347472"/>
-          </a:xfrm>
-          <a:prstGeom prst="rect">
-            <a:avLst/>
-          </a:prstGeom>
-          <a:noFill/>
-          <a:ln/>
-        </p:spPr>
-        <p:txBody>
-          <a:bodyPr wrap="square" lIns="0" tIns="0" rIns="0" bIns="0" rtlCol="0" anchor="ctr"/>
-          <a:lstStyle/>
-          <a:p>
-            <a:pPr marL="0" indent="0" algn="ctr">
-              <a:buNone/>
-            </a:pPr>
-            <a:r>
-              <a:rPr lang="en-US" sz="1400" dirty="0">
-                <a:solidFill>
-                  <a:srgbClr val="E07B39"/>
-                </a:solidFill>
-                <a:latin typeface="Calibri" pitchFamily="34" charset="0"/>
-                <a:ea typeface="Calibri" pitchFamily="34" charset="-122"/>
-                <a:cs typeface="Calibri" pitchFamily="34" charset="-120"/>
-              </a:rPr>
-              <a:t>&gt;</a:t>
-            </a:r>
-            <a:endParaRPr lang="en-US" sz="1400" dirty="0"/>
-          </a:p>
-        </p:txBody>
-      </p:sp>
-      <p:sp>
-        <p:nvSpPr>
-          <p:cNvPr id="15" name="Text 13"/>
-          <p:cNvSpPr/>
-          <p:nvPr/>
-        </p:nvSpPr>
-        <p:spPr>
-          <a:xfrm>
-            <a:off x="850392" y="3712464"/>
-            <a:ext cx="3401568" cy="347472"/>
-          </a:xfrm>
-          <a:prstGeom prst="rect">
-            <a:avLst/>
-          </a:prstGeom>
-          <a:noFill/>
-          <a:ln/>
-        </p:spPr>
-        <p:txBody>
-          <a:bodyPr wrap="square" lIns="0" tIns="0" rIns="0" bIns="0" rtlCol="0" anchor="ctr"/>
-          <a:lstStyle/>
-          <a:p>
-            <a:pPr marL="0" indent="0">
-              <a:buNone/>
-            </a:pPr>
+              <a:t> Anonyme pour </a:t>
+            </a:r>
+            <a:r>
+              <a:rPr lang="en-US" sz="1300" dirty="0" err="1">
+                <a:solidFill>
+                  <a:srgbClr val="F0F6FC"/>
+                </a:solidFill>
+                <a:latin typeface="Calibri" pitchFamily="34" charset="0"/>
+                <a:ea typeface="Calibri" pitchFamily="34" charset="-122"/>
+                <a:cs typeface="Calibri" pitchFamily="34" charset="-120"/>
+              </a:rPr>
+              <a:t>cacher</a:t>
+            </a:r>
             <a:r>
               <a:rPr lang="en-US" sz="1300" dirty="0">
                 <a:solidFill>
@@ -10621,7 +11165,18 @@
                 <a:ea typeface="Calibri" pitchFamily="34" charset="-122"/>
                 <a:cs typeface="Calibri" pitchFamily="34" charset="-120"/>
               </a:rPr>
-              <a:t>Masquee par defaut ('Inconnue') — GM revele</a:t>
+              <a:t> ('Inconnu’) — GM </a:t>
+            </a:r>
+            <a:r>
+              <a:rPr lang="en-US" sz="1300" dirty="0" err="1">
+                <a:solidFill>
+                  <a:srgbClr val="F0F6FC"/>
+                </a:solidFill>
+                <a:latin typeface="Calibri" pitchFamily="34" charset="0"/>
+                <a:ea typeface="Calibri" pitchFamily="34" charset="-122"/>
+                <a:cs typeface="Calibri" pitchFamily="34" charset="-120"/>
+              </a:rPr>
+              <a:t>revele</a:t>
             </a:r>
             <a:endParaRPr lang="en-US" sz="1300" dirty="0"/>
           </a:p>

</xml_diff>